<commit_message>
month long update before changing and modifying the simEnv project
</commit_message>
<xml_diff>
--- a/dataAcquisition/Motec_MP/plot/output/E07_TSV/26VCS_E07TSV_Q21_AR_E07TSV_plotRequest.pptx
+++ b/dataAcquisition/Motec_MP/plot/output/E07_TSV/26VCS_E07TSV_Q21_AR_E07TSV_plotRequest.pptx
@@ -8,14 +8,7 @@
   </p:sldMasterIdLst>
   <p:sldIdLst>
     <p:sldId id="256" r:id="rId7"/>
-    <p:sldId id="258" r:id="rId14"/>
     <p:sldId id="257" r:id="rId8"/>
-    <p:sldId id="259" r:id="rId15"/>
-    <p:sldId id="260" r:id="rId16"/>
-    <p:sldId id="261" r:id="rId17"/>
-    <p:sldId id="262" r:id="rId18"/>
-    <p:sldId id="263" r:id="rId19"/>
-    <p:sldId id="264" r:id="rId20"/>
   </p:sldIdLst>
   <p:sldSz cx="12192000" cy="6858000"/>
   <p:notesSz cx="6858000" cy="9144000"/>
@@ -11125,10 +11118,10 @@
           </a:bodyPr>
           <a:lstStyle/>
           <a:p>
-            <a:r>
-              <a:rPr lang="en-AU" dirty="0"/>
-              <a:t>Supercars Systems Report 2026</a:t>
-            </a:r>
+            <a:endParaRPr lang="en-AU" dirty="0">
+              <a:latin typeface="Rois Extra"/>
+              <a:cs typeface="Poppins"/>
+            </a:endParaRPr>
           </a:p>
         </p:txBody>
       </p:sp>
@@ -11158,28 +11151,7 @@
           <a:bodyPr/>
           <a:lstStyle/>
           <a:p>
-            <a:r>
-              <a:rPr lang="en-AU" sz="1200" dirty="0"/>
-              <a:t>Sessions:</a:t>
-            </a:r>
-          </a:p>
-          <a:p>
-            <a:r>
-              <a:rPr lang="en-AU" sz="1200" dirty="0"/>
-              <a:t>	Q21</a:t>
-            </a:r>
-          </a:p>
-          <a:p>
-            <a:r>
-              <a:rPr lang="en-AU" sz="1200" dirty="0"/>
-              <a:t>Teams:</a:t>
-            </a:r>
-          </a:p>
-          <a:p>
-            <a:r>
-              <a:rPr lang="en-AU" sz="1200" dirty="0"/>
-              <a:t>	</a:t>
-            </a:r>
+            <a:endParaRPr lang="en-AU" dirty="0"/>
           </a:p>
         </p:txBody>
       </p:sp>
@@ -11254,1513 +11226,6 @@
         <p14:creationId xmlns:p14="http://schemas.microsoft.com/office/powerpoint/2010/main" val="2401952684"/>
       </p:ext>
     </p:extLst>
-  </p:cSld>
-  <p:clrMapOvr>
-    <a:masterClrMapping/>
-  </p:clrMapOvr>
-</p:sld>
-</file>
-
-<file path=ppt/slides/slide3.xml><?xml version="1.0" encoding="utf-8"?>
-<p:sld xmlns:a="http://schemas.openxmlformats.org/drawingml/2006/main" xmlns:r="http://schemas.openxmlformats.org/officeDocument/2006/relationships" xmlns:p="http://schemas.openxmlformats.org/presentationml/2006/main">
-  <p:cSld>
-    <p:spTree>
-      <p:nvGrpSpPr>
-        <p:cNvPr id="1" name=""/>
-        <p:cNvGrpSpPr/>
-        <p:nvPr/>
-      </p:nvGrpSpPr>
-      <p:grpSpPr>
-        <a:xfrm>
-          <a:off x="0" y="0"/>
-          <a:ext cx="0" cy="0"/>
-          <a:chOff x="0" y="0"/>
-          <a:chExt cx="0" cy="0"/>
-        </a:xfrm>
-      </p:grpSpPr>
-      <p:sp>
-        <p:nvSpPr>
-          <p:cNvPr id="2" name="TextBox 2"/>
-          <p:cNvSpPr txBox="1"/>
-          <p:nvPr/>
-        </p:nvSpPr>
-        <p:spPr>
-          <a:xfrm>
-            <a:off x="254000" y="152400"/>
-            <a:ext cx="8636000" cy="355600"/>
-          </a:xfrm>
-          <a:prstGeom prst="rect">
-            <a:avLst/>
-          </a:prstGeom>
-          <a:noFill/>
-        </p:spPr>
-        <p:txBody>
-          <a:bodyPr wrap="square" lIns="0" tIns="0" rIns="0" bIns="0" anchor="t">
-            <a:noAutofit/>
-          </a:bodyPr>
-          <a:lstStyle/>
-          <a:p>
-            <a:r>
-              <a:rPr lang="en-AU" sz="1800" b="1" dirty="0">
-                <a:solidFill>
-                  <a:srgbClr val="000000"/>
-                </a:solidFill>
-              </a:rPr>
-              <a:t>Contents</a:t>
-            </a:r>
-          </a:p>
-        </p:txBody>
-      </p:sp>
-      <p:sp>
-        <p:nvSpPr>
-          <p:cNvPr id="3" name="TextBox 3"/>
-          <p:cNvSpPr txBox="1"/>
-          <p:nvPr/>
-        </p:nvSpPr>
-        <p:spPr>
-          <a:xfrm>
-            <a:off x="254000" y="609600"/>
-            <a:ext cx="317500" cy="177800"/>
-          </a:xfrm>
-          <a:prstGeom prst="rect">
-            <a:avLst/>
-          </a:prstGeom>
-          <a:noFill/>
-        </p:spPr>
-        <p:txBody>
-          <a:bodyPr wrap="square" lIns="0" tIns="0" rIns="0" bIns="0" anchor="t">
-            <a:noAutofit/>
-          </a:bodyPr>
-          <a:lstStyle/>
-          <a:p>
-            <a:r>
-              <a:rPr lang="en-AU" sz="900" b="1" dirty="0">
-                <a:solidFill>
-                  <a:srgbClr val="000000"/>
-                </a:solidFill>
-              </a:rPr>
-              <a:t>#</a:t>
-            </a:r>
-          </a:p>
-        </p:txBody>
-      </p:sp>
-      <p:sp>
-        <p:nvSpPr>
-          <p:cNvPr id="4" name="TextBox 4"/>
-          <p:cNvSpPr txBox="1"/>
-          <p:nvPr/>
-        </p:nvSpPr>
-        <p:spPr>
-          <a:xfrm>
-            <a:off x="635000" y="609600"/>
-            <a:ext cx="1270000" cy="177800"/>
-          </a:xfrm>
-          <a:prstGeom prst="rect">
-            <a:avLst/>
-          </a:prstGeom>
-          <a:noFill/>
-        </p:spPr>
-        <p:txBody>
-          <a:bodyPr wrap="square" lIns="0" tIns="0" rIns="0" bIns="0" anchor="t">
-            <a:noAutofit/>
-          </a:bodyPr>
-          <a:lstStyle/>
-          <a:p>
-            <a:r>
-              <a:rPr lang="en-AU" sz="900" b="1" dirty="0">
-                <a:solidFill>
-                  <a:srgbClr val="000000"/>
-                </a:solidFill>
-              </a:rPr>
-              <a:t>Title</a:t>
-            </a:r>
-          </a:p>
-        </p:txBody>
-      </p:sp>
-      <p:sp>
-        <p:nvSpPr>
-          <p:cNvPr id="5" name="TextBox 5"/>
-          <p:cNvSpPr txBox="1"/>
-          <p:nvPr/>
-        </p:nvSpPr>
-        <p:spPr>
-          <a:xfrm>
-            <a:off x="1905000" y="609600"/>
-            <a:ext cx="762000" cy="177800"/>
-          </a:xfrm>
-          <a:prstGeom prst="rect">
-            <a:avLst/>
-          </a:prstGeom>
-          <a:noFill/>
-        </p:spPr>
-        <p:txBody>
-          <a:bodyPr wrap="square" lIns="0" tIns="0" rIns="0" bIns="0" anchor="t">
-            <a:noAutofit/>
-          </a:bodyPr>
-          <a:lstStyle/>
-          <a:p>
-            <a:r>
-              <a:rPr lang="en-AU" sz="900" b="1" dirty="0">
-                <a:solidFill>
-                  <a:srgbClr val="000000"/>
-                </a:solidFill>
-              </a:rPr>
-              <a:t>Math Op</a:t>
-            </a:r>
-          </a:p>
-        </p:txBody>
-      </p:sp>
-      <p:sp>
-        <p:nvSpPr>
-          <p:cNvPr id="6" name="TextBox 6"/>
-          <p:cNvSpPr txBox="1"/>
-          <p:nvPr/>
-        </p:nvSpPr>
-        <p:spPr>
-          <a:xfrm>
-            <a:off x="2984500" y="609600"/>
-            <a:ext cx="1016000" cy="177800"/>
-          </a:xfrm>
-          <a:prstGeom prst="rect">
-            <a:avLst/>
-          </a:prstGeom>
-          <a:noFill/>
-        </p:spPr>
-        <p:txBody>
-          <a:bodyPr wrap="square" lIns="0" tIns="0" rIns="0" bIns="0" anchor="t">
-            <a:noAutofit/>
-          </a:bodyPr>
-          <a:lstStyle/>
-          <a:p>
-            <a:r>
-              <a:rPr lang="en-AU" sz="900" b="1" dirty="0">
-                <a:solidFill>
-                  <a:srgbClr val="000000"/>
-                </a:solidFill>
-              </a:rPr>
-              <a:t>Plot Type</a:t>
-            </a:r>
-          </a:p>
-        </p:txBody>
-      </p:sp>
-      <p:sp>
-        <p:nvSpPr>
-          <p:cNvPr id="7" name="TextBox 7"/>
-          <p:cNvSpPr txBox="1"/>
-          <p:nvPr/>
-        </p:nvSpPr>
-        <p:spPr>
-          <a:xfrm>
-            <a:off x="3873500" y="609600"/>
-            <a:ext cx="889000" cy="177800"/>
-          </a:xfrm>
-          <a:prstGeom prst="rect">
-            <a:avLst/>
-          </a:prstGeom>
-          <a:noFill/>
-        </p:spPr>
-        <p:txBody>
-          <a:bodyPr wrap="square" lIns="0" tIns="0" rIns="0" bIns="0" anchor="t">
-            <a:noAutofit/>
-          </a:bodyPr>
-          <a:lstStyle/>
-          <a:p>
-            <a:r>
-              <a:rPr lang="en-AU" sz="900" b="1" dirty="0">
-                <a:solidFill>
-                  <a:srgbClr val="000000"/>
-                </a:solidFill>
-              </a:rPr>
-              <a:t>Colours</a:t>
-            </a:r>
-          </a:p>
-        </p:txBody>
-      </p:sp>
-      <p:sp>
-        <p:nvSpPr>
-          <p:cNvPr id="8" name="TextBox 8"/>
-          <p:cNvSpPr txBox="1"/>
-          <p:nvPr/>
-        </p:nvSpPr>
-        <p:spPr>
-          <a:xfrm>
-            <a:off x="254000" y="812800"/>
-            <a:ext cx="317500" cy="203200"/>
-          </a:xfrm>
-          <a:prstGeom prst="rect">
-            <a:avLst/>
-          </a:prstGeom>
-          <a:noFill/>
-        </p:spPr>
-        <p:txBody>
-          <a:bodyPr wrap="square" lIns="0" tIns="0" rIns="0" bIns="0" anchor="t">
-            <a:noAutofit/>
-          </a:bodyPr>
-          <a:lstStyle/>
-          <a:p>
-            <a:r>
-              <a:rPr lang="en-AU" sz="900" b="0" dirty="0">
-                <a:solidFill>
-                  <a:srgbClr val="000000"/>
-                </a:solidFill>
-              </a:rPr>
-              <a:t>1</a:t>
-            </a:r>
-          </a:p>
-        </p:txBody>
-      </p:sp>
-      <p:sp>
-        <p:nvSpPr>
-          <p:cNvPr id="9" name="TextBox 9"/>
-          <p:cNvSpPr txBox="1"/>
-          <p:nvPr/>
-        </p:nvSpPr>
-        <p:spPr>
-          <a:xfrm>
-            <a:off x="635000" y="812800"/>
-            <a:ext cx="1270000" cy="203200"/>
-          </a:xfrm>
-          <a:prstGeom prst="rect">
-            <a:avLst/>
-          </a:prstGeom>
-          <a:noFill/>
-        </p:spPr>
-        <p:txBody>
-          <a:bodyPr wrap="square" lIns="0" tIns="0" rIns="0" bIns="0" anchor="t">
-            <a:noAutofit/>
-          </a:bodyPr>
-          <a:lstStyle/>
-          <a:p>
-            <a:r>
-              <a:rPr lang="en-AU" sz="900" b="0" dirty="0">
-                <a:solidFill>
-                  <a:srgbClr val="000000"/>
-                </a:solidFill>
-              </a:rPr>
-              <a:t>Cz Total Gated Aero Plot</a:t>
-            </a:r>
-          </a:p>
-        </p:txBody>
-      </p:sp>
-      <p:sp>
-        <p:nvSpPr>
-          <p:cNvPr id="10" name="TextBox 10"/>
-          <p:cNvSpPr txBox="1"/>
-          <p:nvPr/>
-        </p:nvSpPr>
-        <p:spPr>
-          <a:xfrm>
-            <a:off x="1905000" y="812800"/>
-            <a:ext cx="762000" cy="203200"/>
-          </a:xfrm>
-          <a:prstGeom prst="rect">
-            <a:avLst/>
-          </a:prstGeom>
-          <a:noFill/>
-        </p:spPr>
-        <p:txBody>
-          <a:bodyPr wrap="square" lIns="0" tIns="0" rIns="0" bIns="0" anchor="t">
-            <a:noAutofit/>
-          </a:bodyPr>
-          <a:lstStyle/>
-          <a:p>
-            <a:r>
-              <a:rPr lang="en-AU" sz="900" b="0" dirty="0">
-                <a:solidFill>
-                  <a:srgbClr val="000000"/>
-                </a:solidFill>
-              </a:rPr>
-              <a:t>mean non zero</a:t>
-            </a:r>
-          </a:p>
-        </p:txBody>
-      </p:sp>
-      <p:sp>
-        <p:nvSpPr>
-          <p:cNvPr id="11" name="TextBox 11"/>
-          <p:cNvSpPr txBox="1"/>
-          <p:nvPr/>
-        </p:nvSpPr>
-        <p:spPr>
-          <a:xfrm>
-            <a:off x="2984500" y="812800"/>
-            <a:ext cx="1016000" cy="203200"/>
-          </a:xfrm>
-          <a:prstGeom prst="rect">
-            <a:avLst/>
-          </a:prstGeom>
-          <a:noFill/>
-        </p:spPr>
-        <p:txBody>
-          <a:bodyPr wrap="square" lIns="0" tIns="0" rIns="0" bIns="0" anchor="t">
-            <a:noAutofit/>
-          </a:bodyPr>
-          <a:lstStyle/>
-          <a:p>
-            <a:r>
-              <a:rPr lang="en-AU" sz="900" b="0" dirty="0">
-                <a:solidFill>
-                  <a:srgbClr val="000000"/>
-                </a:solidFill>
-              </a:rPr>
-              <a:t>phase_profile</a:t>
-            </a:r>
-          </a:p>
-        </p:txBody>
-      </p:sp>
-      <p:sp>
-        <p:nvSpPr>
-          <p:cNvPr id="12" name="TextBox 12"/>
-          <p:cNvSpPr txBox="1"/>
-          <p:nvPr/>
-        </p:nvSpPr>
-        <p:spPr>
-          <a:xfrm>
-            <a:off x="3873500" y="812800"/>
-            <a:ext cx="889000" cy="203200"/>
-          </a:xfrm>
-          <a:prstGeom prst="rect">
-            <a:avLst/>
-          </a:prstGeom>
-          <a:noFill/>
-        </p:spPr>
-        <p:txBody>
-          <a:bodyPr wrap="square" lIns="0" tIns="0" rIns="0" bIns="0" anchor="t">
-            <a:noAutofit/>
-          </a:bodyPr>
-          <a:lstStyle/>
-          <a:p>
-            <a:r>
-              <a:rPr lang="en-AU" sz="900" b="0" dirty="0">
-                <a:solidFill>
-                  <a:srgbClr val="000000"/>
-                </a:solidFill>
-              </a:rPr>
-              <a:t>manufacturer</a:t>
-            </a:r>
-          </a:p>
-        </p:txBody>
-      </p:sp>
-      <p:sp>
-        <p:nvSpPr>
-          <p:cNvPr id="13" name="TextBox 13"/>
-          <p:cNvSpPr txBox="1"/>
-          <p:nvPr/>
-        </p:nvSpPr>
-        <p:spPr>
-          <a:xfrm>
-            <a:off x="254000" y="1016000"/>
-            <a:ext cx="317500" cy="203200"/>
-          </a:xfrm>
-          <a:prstGeom prst="rect">
-            <a:avLst/>
-          </a:prstGeom>
-          <a:noFill/>
-        </p:spPr>
-        <p:txBody>
-          <a:bodyPr wrap="square" lIns="0" tIns="0" rIns="0" bIns="0" anchor="t">
-            <a:noAutofit/>
-          </a:bodyPr>
-          <a:lstStyle/>
-          <a:p>
-            <a:r>
-              <a:rPr lang="en-AU" sz="900" b="0" dirty="0">
-                <a:solidFill>
-                  <a:srgbClr val="000000"/>
-                </a:solidFill>
-              </a:rPr>
-              <a:t>2</a:t>
-            </a:r>
-          </a:p>
-        </p:txBody>
-      </p:sp>
-      <p:sp>
-        <p:nvSpPr>
-          <p:cNvPr id="14" name="TextBox 14"/>
-          <p:cNvSpPr txBox="1"/>
-          <p:nvPr/>
-        </p:nvSpPr>
-        <p:spPr>
-          <a:xfrm>
-            <a:off x="635000" y="1016000"/>
-            <a:ext cx="1270000" cy="203200"/>
-          </a:xfrm>
-          <a:prstGeom prst="rect">
-            <a:avLst/>
-          </a:prstGeom>
-          <a:noFill/>
-        </p:spPr>
-        <p:txBody>
-          <a:bodyPr wrap="square" lIns="0" tIns="0" rIns="0" bIns="0" anchor="t">
-            <a:noAutofit/>
-          </a:bodyPr>
-          <a:lstStyle/>
-          <a:p>
-            <a:r>
-              <a:rPr lang="en-AU" sz="900" b="0" dirty="0">
-                <a:solidFill>
-                  <a:srgbClr val="000000"/>
-                </a:solidFill>
-              </a:rPr>
-              <a:t>Cx Binned Cx Gates</a:t>
-            </a:r>
-          </a:p>
-        </p:txBody>
-      </p:sp>
-      <p:sp>
-        <p:nvSpPr>
-          <p:cNvPr id="15" name="TextBox 15"/>
-          <p:cNvSpPr txBox="1"/>
-          <p:nvPr/>
-        </p:nvSpPr>
-        <p:spPr>
-          <a:xfrm>
-            <a:off x="1905000" y="1016000"/>
-            <a:ext cx="762000" cy="203200"/>
-          </a:xfrm>
-          <a:prstGeom prst="rect">
-            <a:avLst/>
-          </a:prstGeom>
-          <a:noFill/>
-        </p:spPr>
-        <p:txBody>
-          <a:bodyPr wrap="square" lIns="0" tIns="0" rIns="0" bIns="0" anchor="t">
-            <a:noAutofit/>
-          </a:bodyPr>
-          <a:lstStyle/>
-          <a:p>
-            <a:r>
-              <a:rPr lang="en-AU" sz="900" b="0" dirty="0">
-                <a:solidFill>
-                  <a:srgbClr val="000000"/>
-                </a:solidFill>
-              </a:rPr>
-              <a:t>mean non zero</a:t>
-            </a:r>
-          </a:p>
-        </p:txBody>
-      </p:sp>
-      <p:sp>
-        <p:nvSpPr>
-          <p:cNvPr id="16" name="TextBox 16"/>
-          <p:cNvSpPr txBox="1"/>
-          <p:nvPr/>
-        </p:nvSpPr>
-        <p:spPr>
-          <a:xfrm>
-            <a:off x="2984500" y="1016000"/>
-            <a:ext cx="1016000" cy="203200"/>
-          </a:xfrm>
-          <a:prstGeom prst="rect">
-            <a:avLst/>
-          </a:prstGeom>
-          <a:noFill/>
-        </p:spPr>
-        <p:txBody>
-          <a:bodyPr wrap="square" lIns="0" tIns="0" rIns="0" bIns="0" anchor="t">
-            <a:noAutofit/>
-          </a:bodyPr>
-          <a:lstStyle/>
-          <a:p>
-            <a:r>
-              <a:rPr lang="en-AU" sz="900" b="0" dirty="0">
-                <a:solidFill>
-                  <a:srgbClr val="000000"/>
-                </a:solidFill>
-              </a:rPr>
-              <a:t>phase_profile</a:t>
-            </a:r>
-          </a:p>
-        </p:txBody>
-      </p:sp>
-      <p:sp>
-        <p:nvSpPr>
-          <p:cNvPr id="17" name="TextBox 17"/>
-          <p:cNvSpPr txBox="1"/>
-          <p:nvPr/>
-        </p:nvSpPr>
-        <p:spPr>
-          <a:xfrm>
-            <a:off x="3873500" y="1016000"/>
-            <a:ext cx="889000" cy="203200"/>
-          </a:xfrm>
-          <a:prstGeom prst="rect">
-            <a:avLst/>
-          </a:prstGeom>
-          <a:noFill/>
-        </p:spPr>
-        <p:txBody>
-          <a:bodyPr wrap="square" lIns="0" tIns="0" rIns="0" bIns="0" anchor="t">
-            <a:noAutofit/>
-          </a:bodyPr>
-          <a:lstStyle/>
-          <a:p>
-            <a:r>
-              <a:rPr lang="en-AU" sz="900" b="0" dirty="0">
-                <a:solidFill>
-                  <a:srgbClr val="000000"/>
-                </a:solidFill>
-              </a:rPr>
-              <a:t>manufacturer</a:t>
-            </a:r>
-          </a:p>
-        </p:txBody>
-      </p:sp>
-      <p:sp>
-        <p:nvSpPr>
-          <p:cNvPr id="18" name="TextBox 18"/>
-          <p:cNvSpPr txBox="1"/>
-          <p:nvPr/>
-        </p:nvSpPr>
-        <p:spPr>
-          <a:xfrm>
-            <a:off x="254000" y="1219200"/>
-            <a:ext cx="317500" cy="203200"/>
-          </a:xfrm>
-          <a:prstGeom prst="rect">
-            <a:avLst/>
-          </a:prstGeom>
-          <a:noFill/>
-        </p:spPr>
-        <p:txBody>
-          <a:bodyPr wrap="square" lIns="0" tIns="0" rIns="0" bIns="0" anchor="t">
-            <a:noAutofit/>
-          </a:bodyPr>
-          <a:lstStyle/>
-          <a:p>
-            <a:r>
-              <a:rPr lang="en-AU" sz="900" b="0" dirty="0">
-                <a:solidFill>
-                  <a:srgbClr val="000000"/>
-                </a:solidFill>
-              </a:rPr>
-              <a:t>3</a:t>
-            </a:r>
-          </a:p>
-        </p:txBody>
-      </p:sp>
-      <p:sp>
-        <p:nvSpPr>
-          <p:cNvPr id="19" name="TextBox 19"/>
-          <p:cNvSpPr txBox="1"/>
-          <p:nvPr/>
-        </p:nvSpPr>
-        <p:spPr>
-          <a:xfrm>
-            <a:off x="635000" y="1219200"/>
-            <a:ext cx="1270000" cy="203200"/>
-          </a:xfrm>
-          <a:prstGeom prst="rect">
-            <a:avLst/>
-          </a:prstGeom>
-          <a:noFill/>
-        </p:spPr>
-        <p:txBody>
-          <a:bodyPr wrap="square" lIns="0" tIns="0" rIns="0" bIns="0" anchor="t">
-            <a:noAutofit/>
-          </a:bodyPr>
-          <a:lstStyle/>
-          <a:p>
-            <a:r>
-              <a:rPr lang="en-AU" sz="900" b="0" dirty="0">
-                <a:solidFill>
-                  <a:srgbClr val="000000"/>
-                </a:solidFill>
-              </a:rPr>
-              <a:t>Balance % Front</a:t>
-            </a:r>
-          </a:p>
-        </p:txBody>
-      </p:sp>
-      <p:sp>
-        <p:nvSpPr>
-          <p:cNvPr id="20" name="TextBox 20"/>
-          <p:cNvSpPr txBox="1"/>
-          <p:nvPr/>
-        </p:nvSpPr>
-        <p:spPr>
-          <a:xfrm>
-            <a:off x="1905000" y="1219200"/>
-            <a:ext cx="762000" cy="203200"/>
-          </a:xfrm>
-          <a:prstGeom prst="rect">
-            <a:avLst/>
-          </a:prstGeom>
-          <a:noFill/>
-        </p:spPr>
-        <p:txBody>
-          <a:bodyPr wrap="square" lIns="0" tIns="0" rIns="0" bIns="0" anchor="t">
-            <a:noAutofit/>
-          </a:bodyPr>
-          <a:lstStyle/>
-          <a:p>
-            <a:r>
-              <a:rPr lang="en-AU" sz="900" b="0" dirty="0">
-                <a:solidFill>
-                  <a:srgbClr val="000000"/>
-                </a:solidFill>
-              </a:rPr>
-              <a:t>mean non zero</a:t>
-            </a:r>
-          </a:p>
-        </p:txBody>
-      </p:sp>
-      <p:sp>
-        <p:nvSpPr>
-          <p:cNvPr id="21" name="TextBox 21"/>
-          <p:cNvSpPr txBox="1"/>
-          <p:nvPr/>
-        </p:nvSpPr>
-        <p:spPr>
-          <a:xfrm>
-            <a:off x="2984500" y="1219200"/>
-            <a:ext cx="1016000" cy="203200"/>
-          </a:xfrm>
-          <a:prstGeom prst="rect">
-            <a:avLst/>
-          </a:prstGeom>
-          <a:noFill/>
-        </p:spPr>
-        <p:txBody>
-          <a:bodyPr wrap="square" lIns="0" tIns="0" rIns="0" bIns="0" anchor="t">
-            <a:noAutofit/>
-          </a:bodyPr>
-          <a:lstStyle/>
-          <a:p>
-            <a:r>
-              <a:rPr lang="en-AU" sz="900" b="0" dirty="0">
-                <a:solidFill>
-                  <a:srgbClr val="000000"/>
-                </a:solidFill>
-              </a:rPr>
-              <a:t>phase_profile</a:t>
-            </a:r>
-          </a:p>
-        </p:txBody>
-      </p:sp>
-      <p:sp>
-        <p:nvSpPr>
-          <p:cNvPr id="22" name="TextBox 22"/>
-          <p:cNvSpPr txBox="1"/>
-          <p:nvPr/>
-        </p:nvSpPr>
-        <p:spPr>
-          <a:xfrm>
-            <a:off x="3873500" y="1219200"/>
-            <a:ext cx="889000" cy="203200"/>
-          </a:xfrm>
-          <a:prstGeom prst="rect">
-            <a:avLst/>
-          </a:prstGeom>
-          <a:noFill/>
-        </p:spPr>
-        <p:txBody>
-          <a:bodyPr wrap="square" lIns="0" tIns="0" rIns="0" bIns="0" anchor="t">
-            <a:noAutofit/>
-          </a:bodyPr>
-          <a:lstStyle/>
-          <a:p>
-            <a:r>
-              <a:rPr lang="en-AU" sz="900" b="0" dirty="0">
-                <a:solidFill>
-                  <a:srgbClr val="000000"/>
-                </a:solidFill>
-              </a:rPr>
-              <a:t>manufacturer</a:t>
-            </a:r>
-          </a:p>
-        </p:txBody>
-      </p:sp>
-      <p:sp>
-        <p:nvSpPr>
-          <p:cNvPr id="23" name="TextBox 23"/>
-          <p:cNvSpPr txBox="1"/>
-          <p:nvPr/>
-        </p:nvSpPr>
-        <p:spPr>
-          <a:xfrm>
-            <a:off x="254000" y="1422400"/>
-            <a:ext cx="317500" cy="203200"/>
-          </a:xfrm>
-          <a:prstGeom prst="rect">
-            <a:avLst/>
-          </a:prstGeom>
-          <a:noFill/>
-        </p:spPr>
-        <p:txBody>
-          <a:bodyPr wrap="square" lIns="0" tIns="0" rIns="0" bIns="0" anchor="t">
-            <a:noAutofit/>
-          </a:bodyPr>
-          <a:lstStyle/>
-          <a:p>
-            <a:r>
-              <a:rPr lang="en-AU" sz="900" b="0" dirty="0">
-                <a:solidFill>
-                  <a:srgbClr val="000000"/>
-                </a:solidFill>
-              </a:rPr>
-              <a:t>4</a:t>
-            </a:r>
-          </a:p>
-        </p:txBody>
-      </p:sp>
-      <p:sp>
-        <p:nvSpPr>
-          <p:cNvPr id="24" name="TextBox 24"/>
-          <p:cNvSpPr txBox="1"/>
-          <p:nvPr/>
-        </p:nvSpPr>
-        <p:spPr>
-          <a:xfrm>
-            <a:off x="635000" y="1422400"/>
-            <a:ext cx="1270000" cy="203200"/>
-          </a:xfrm>
-          <a:prstGeom prst="rect">
-            <a:avLst/>
-          </a:prstGeom>
-          <a:noFill/>
-        </p:spPr>
-        <p:txBody>
-          <a:bodyPr wrap="square" lIns="0" tIns="0" rIns="0" bIns="0" anchor="t">
-            <a:noAutofit/>
-          </a:bodyPr>
-          <a:lstStyle/>
-          <a:p>
-            <a:r>
-              <a:rPr lang="en-AU" sz="900" b="0" dirty="0">
-                <a:solidFill>
-                  <a:srgbClr val="000000"/>
-                </a:solidFill>
-              </a:rPr>
-              <a:t>Aero Efficiency</a:t>
-            </a:r>
-          </a:p>
-        </p:txBody>
-      </p:sp>
-      <p:sp>
-        <p:nvSpPr>
-          <p:cNvPr id="25" name="TextBox 25"/>
-          <p:cNvSpPr txBox="1"/>
-          <p:nvPr/>
-        </p:nvSpPr>
-        <p:spPr>
-          <a:xfrm>
-            <a:off x="1905000" y="1422400"/>
-            <a:ext cx="762000" cy="203200"/>
-          </a:xfrm>
-          <a:prstGeom prst="rect">
-            <a:avLst/>
-          </a:prstGeom>
-          <a:noFill/>
-        </p:spPr>
-        <p:txBody>
-          <a:bodyPr wrap="square" lIns="0" tIns="0" rIns="0" bIns="0" anchor="t">
-            <a:noAutofit/>
-          </a:bodyPr>
-          <a:lstStyle/>
-          <a:p>
-            <a:r>
-              <a:rPr lang="en-AU" sz="900" b="0" dirty="0">
-                <a:solidFill>
-                  <a:srgbClr val="000000"/>
-                </a:solidFill>
-              </a:rPr>
-              <a:t>mean non zero</a:t>
-            </a:r>
-          </a:p>
-        </p:txBody>
-      </p:sp>
-      <p:sp>
-        <p:nvSpPr>
-          <p:cNvPr id="26" name="TextBox 26"/>
-          <p:cNvSpPr txBox="1"/>
-          <p:nvPr/>
-        </p:nvSpPr>
-        <p:spPr>
-          <a:xfrm>
-            <a:off x="2984500" y="1422400"/>
-            <a:ext cx="1016000" cy="203200"/>
-          </a:xfrm>
-          <a:prstGeom prst="rect">
-            <a:avLst/>
-          </a:prstGeom>
-          <a:noFill/>
-        </p:spPr>
-        <p:txBody>
-          <a:bodyPr wrap="square" lIns="0" tIns="0" rIns="0" bIns="0" anchor="t">
-            <a:noAutofit/>
-          </a:bodyPr>
-          <a:lstStyle/>
-          <a:p>
-            <a:r>
-              <a:rPr lang="en-AU" sz="900" b="0" dirty="0">
-                <a:solidFill>
-                  <a:srgbClr val="000000"/>
-                </a:solidFill>
-              </a:rPr>
-              <a:t>phase_profile</a:t>
-            </a:r>
-          </a:p>
-        </p:txBody>
-      </p:sp>
-      <p:sp>
-        <p:nvSpPr>
-          <p:cNvPr id="27" name="TextBox 27"/>
-          <p:cNvSpPr txBox="1"/>
-          <p:nvPr/>
-        </p:nvSpPr>
-        <p:spPr>
-          <a:xfrm>
-            <a:off x="3873500" y="1422400"/>
-            <a:ext cx="889000" cy="203200"/>
-          </a:xfrm>
-          <a:prstGeom prst="rect">
-            <a:avLst/>
-          </a:prstGeom>
-          <a:noFill/>
-        </p:spPr>
-        <p:txBody>
-          <a:bodyPr wrap="square" lIns="0" tIns="0" rIns="0" bIns="0" anchor="t">
-            <a:noAutofit/>
-          </a:bodyPr>
-          <a:lstStyle/>
-          <a:p>
-            <a:r>
-              <a:rPr lang="en-AU" sz="900" b="0" dirty="0">
-                <a:solidFill>
-                  <a:srgbClr val="000000"/>
-                </a:solidFill>
-              </a:rPr>
-              <a:t>manufacturer</a:t>
-            </a:r>
-          </a:p>
-        </p:txBody>
-      </p:sp>
-      <p:sp>
-        <p:nvSpPr>
-          <p:cNvPr id="28" name="TextBox 28"/>
-          <p:cNvSpPr txBox="1"/>
-          <p:nvPr/>
-        </p:nvSpPr>
-        <p:spPr>
-          <a:xfrm>
-            <a:off x="254000" y="1625600"/>
-            <a:ext cx="317500" cy="203200"/>
-          </a:xfrm>
-          <a:prstGeom prst="rect">
-            <a:avLst/>
-          </a:prstGeom>
-          <a:noFill/>
-        </p:spPr>
-        <p:txBody>
-          <a:bodyPr wrap="square" lIns="0" tIns="0" rIns="0" bIns="0" anchor="t">
-            <a:noAutofit/>
-          </a:bodyPr>
-          <a:lstStyle/>
-          <a:p>
-            <a:r>
-              <a:rPr lang="en-AU" sz="900" b="0" dirty="0">
-                <a:solidFill>
-                  <a:srgbClr val="000000"/>
-                </a:solidFill>
-              </a:rPr>
-              <a:t>5</a:t>
-            </a:r>
-          </a:p>
-        </p:txBody>
-      </p:sp>
-      <p:sp>
-        <p:nvSpPr>
-          <p:cNvPr id="29" name="TextBox 29"/>
-          <p:cNvSpPr txBox="1"/>
-          <p:nvPr/>
-        </p:nvSpPr>
-        <p:spPr>
-          <a:xfrm>
-            <a:off x="635000" y="1625600"/>
-            <a:ext cx="1270000" cy="203200"/>
-          </a:xfrm>
-          <a:prstGeom prst="rect">
-            <a:avLst/>
-          </a:prstGeom>
-          <a:noFill/>
-        </p:spPr>
-        <p:txBody>
-          <a:bodyPr wrap="square" lIns="0" tIns="0" rIns="0" bIns="0" anchor="t">
-            <a:noAutofit/>
-          </a:bodyPr>
-          <a:lstStyle/>
-          <a:p>
-            <a:r>
-              <a:rPr lang="en-AU" sz="900" b="0" dirty="0">
-                <a:solidFill>
-                  <a:srgbClr val="000000"/>
-                </a:solidFill>
-              </a:rPr>
-              <a:t>Side Force</a:t>
-            </a:r>
-          </a:p>
-        </p:txBody>
-      </p:sp>
-      <p:sp>
-        <p:nvSpPr>
-          <p:cNvPr id="30" name="TextBox 30"/>
-          <p:cNvSpPr txBox="1"/>
-          <p:nvPr/>
-        </p:nvSpPr>
-        <p:spPr>
-          <a:xfrm>
-            <a:off x="1905000" y="1625600"/>
-            <a:ext cx="762000" cy="203200"/>
-          </a:xfrm>
-          <a:prstGeom prst="rect">
-            <a:avLst/>
-          </a:prstGeom>
-          <a:noFill/>
-        </p:spPr>
-        <p:txBody>
-          <a:bodyPr wrap="square" lIns="0" tIns="0" rIns="0" bIns="0" anchor="t">
-            <a:noAutofit/>
-          </a:bodyPr>
-          <a:lstStyle/>
-          <a:p>
-            <a:r>
-              <a:rPr lang="en-AU" sz="900" b="0" dirty="0">
-                <a:solidFill>
-                  <a:srgbClr val="000000"/>
-                </a:solidFill>
-              </a:rPr>
-              <a:t>mean non zero</a:t>
-            </a:r>
-          </a:p>
-        </p:txBody>
-      </p:sp>
-      <p:sp>
-        <p:nvSpPr>
-          <p:cNvPr id="31" name="TextBox 31"/>
-          <p:cNvSpPr txBox="1"/>
-          <p:nvPr/>
-        </p:nvSpPr>
-        <p:spPr>
-          <a:xfrm>
-            <a:off x="2984500" y="1625600"/>
-            <a:ext cx="1016000" cy="203200"/>
-          </a:xfrm>
-          <a:prstGeom prst="rect">
-            <a:avLst/>
-          </a:prstGeom>
-          <a:noFill/>
-        </p:spPr>
-        <p:txBody>
-          <a:bodyPr wrap="square" lIns="0" tIns="0" rIns="0" bIns="0" anchor="t">
-            <a:noAutofit/>
-          </a:bodyPr>
-          <a:lstStyle/>
-          <a:p>
-            <a:r>
-              <a:rPr lang="en-AU" sz="900" b="0" dirty="0">
-                <a:solidFill>
-                  <a:srgbClr val="000000"/>
-                </a:solidFill>
-              </a:rPr>
-              <a:t>phase_profile</a:t>
-            </a:r>
-          </a:p>
-        </p:txBody>
-      </p:sp>
-      <p:sp>
-        <p:nvSpPr>
-          <p:cNvPr id="32" name="TextBox 32"/>
-          <p:cNvSpPr txBox="1"/>
-          <p:nvPr/>
-        </p:nvSpPr>
-        <p:spPr>
-          <a:xfrm>
-            <a:off x="3873500" y="1625600"/>
-            <a:ext cx="889000" cy="203200"/>
-          </a:xfrm>
-          <a:prstGeom prst="rect">
-            <a:avLst/>
-          </a:prstGeom>
-          <a:noFill/>
-        </p:spPr>
-        <p:txBody>
-          <a:bodyPr wrap="square" lIns="0" tIns="0" rIns="0" bIns="0" anchor="t">
-            <a:noAutofit/>
-          </a:bodyPr>
-          <a:lstStyle/>
-          <a:p>
-            <a:r>
-              <a:rPr lang="en-AU" sz="900" b="0" dirty="0">
-                <a:solidFill>
-                  <a:srgbClr val="000000"/>
-                </a:solidFill>
-              </a:rPr>
-              <a:t>manufacturer</a:t>
-            </a:r>
-          </a:p>
-        </p:txBody>
-      </p:sp>
-      <p:sp>
-        <p:nvSpPr>
-          <p:cNvPr id="33" name="TextBox 33"/>
-          <p:cNvSpPr txBox="1"/>
-          <p:nvPr/>
-        </p:nvSpPr>
-        <p:spPr>
-          <a:xfrm>
-            <a:off x="254000" y="1828800"/>
-            <a:ext cx="317500" cy="203200"/>
-          </a:xfrm>
-          <a:prstGeom prst="rect">
-            <a:avLst/>
-          </a:prstGeom>
-          <a:noFill/>
-        </p:spPr>
-        <p:txBody>
-          <a:bodyPr wrap="square" lIns="0" tIns="0" rIns="0" bIns="0" anchor="t">
-            <a:noAutofit/>
-          </a:bodyPr>
-          <a:lstStyle/>
-          <a:p>
-            <a:r>
-              <a:rPr lang="en-AU" sz="900" b="0" dirty="0">
-                <a:solidFill>
-                  <a:srgbClr val="000000"/>
-                </a:solidFill>
-              </a:rPr>
-              <a:t>6</a:t>
-            </a:r>
-          </a:p>
-        </p:txBody>
-      </p:sp>
-      <p:sp>
-        <p:nvSpPr>
-          <p:cNvPr id="34" name="TextBox 34"/>
-          <p:cNvSpPr txBox="1"/>
-          <p:nvPr/>
-        </p:nvSpPr>
-        <p:spPr>
-          <a:xfrm>
-            <a:off x="635000" y="1828800"/>
-            <a:ext cx="1270000" cy="203200"/>
-          </a:xfrm>
-          <a:prstGeom prst="rect">
-            <a:avLst/>
-          </a:prstGeom>
-          <a:noFill/>
-        </p:spPr>
-        <p:txBody>
-          <a:bodyPr wrap="square" lIns="0" tIns="0" rIns="0" bIns="0" anchor="t">
-            <a:noAutofit/>
-          </a:bodyPr>
-          <a:lstStyle/>
-          <a:p>
-            <a:r>
-              <a:rPr lang="en-AU" sz="900" b="0" dirty="0">
-                <a:solidFill>
-                  <a:srgbClr val="000000"/>
-                </a:solidFill>
-              </a:rPr>
-              <a:t>Time Series Total Cz</a:t>
-            </a:r>
-          </a:p>
-        </p:txBody>
-      </p:sp>
-      <p:sp>
-        <p:nvSpPr>
-          <p:cNvPr id="35" name="TextBox 35"/>
-          <p:cNvSpPr txBox="1"/>
-          <p:nvPr/>
-        </p:nvSpPr>
-        <p:spPr>
-          <a:xfrm>
-            <a:off x="1905000" y="1828800"/>
-            <a:ext cx="762000" cy="203200"/>
-          </a:xfrm>
-          <a:prstGeom prst="rect">
-            <a:avLst/>
-          </a:prstGeom>
-          <a:noFill/>
-        </p:spPr>
-        <p:txBody>
-          <a:bodyPr wrap="square" lIns="0" tIns="0" rIns="0" bIns="0" anchor="t">
-            <a:noAutofit/>
-          </a:bodyPr>
-          <a:lstStyle/>
-          <a:p>
-            <a:r>
-              <a:rPr lang="en-AU" sz="900" b="0" dirty="0">
-                <a:solidFill>
-                  <a:srgbClr val="000000"/>
-                </a:solidFill>
-              </a:rPr>
-              <a:t>none</a:t>
-            </a:r>
-          </a:p>
-        </p:txBody>
-      </p:sp>
-      <p:sp>
-        <p:nvSpPr>
-          <p:cNvPr id="36" name="TextBox 36"/>
-          <p:cNvSpPr txBox="1"/>
-          <p:nvPr/>
-        </p:nvSpPr>
-        <p:spPr>
-          <a:xfrm>
-            <a:off x="2984500" y="1828800"/>
-            <a:ext cx="1016000" cy="203200"/>
-          </a:xfrm>
-          <a:prstGeom prst="rect">
-            <a:avLst/>
-          </a:prstGeom>
-          <a:noFill/>
-        </p:spPr>
-        <p:txBody>
-          <a:bodyPr wrap="square" lIns="0" tIns="0" rIns="0" bIns="0" anchor="t">
-            <a:noAutofit/>
-          </a:bodyPr>
-          <a:lstStyle/>
-          <a:p>
-            <a:r>
-              <a:rPr lang="en-AU" sz="900" b="0" dirty="0">
-                <a:solidFill>
-                  <a:srgbClr val="000000"/>
-                </a:solidFill>
-              </a:rPr>
-              <a:t>timeseries</a:t>
-            </a:r>
-          </a:p>
-        </p:txBody>
-      </p:sp>
-      <p:sp>
-        <p:nvSpPr>
-          <p:cNvPr id="37" name="TextBox 37"/>
-          <p:cNvSpPr txBox="1"/>
-          <p:nvPr/>
-        </p:nvSpPr>
-        <p:spPr>
-          <a:xfrm>
-            <a:off x="3873500" y="1828800"/>
-            <a:ext cx="889000" cy="203200"/>
-          </a:xfrm>
-          <a:prstGeom prst="rect">
-            <a:avLst/>
-          </a:prstGeom>
-          <a:noFill/>
-        </p:spPr>
-        <p:txBody>
-          <a:bodyPr wrap="square" lIns="0" tIns="0" rIns="0" bIns="0" anchor="t">
-            <a:noAutofit/>
-          </a:bodyPr>
-          <a:lstStyle/>
-          <a:p>
-            <a:r>
-              <a:rPr lang="en-AU" sz="900" b="0" dirty="0">
-                <a:solidFill>
-                  <a:srgbClr val="000000"/>
-                </a:solidFill>
-              </a:rPr>
-              <a:t>manufacturer</a:t>
-            </a:r>
-          </a:p>
-        </p:txBody>
-      </p:sp>
-    </p:spTree>
-  </p:cSld>
-  <p:clrMapOvr>
-    <a:masterClrMapping/>
-  </p:clrMapOvr>
-</p:sld>
-</file>
-
-<file path=ppt/slides/slide4.xml><?xml version="1.0" encoding="utf-8"?>
-<p:sld xmlns:a="http://schemas.openxmlformats.org/drawingml/2006/main" xmlns:r="http://schemas.openxmlformats.org/officeDocument/2006/relationships" xmlns:p="http://schemas.openxmlformats.org/presentationml/2006/main">
-  <p:cSld>
-    <p:spTree>
-      <p:nvGrpSpPr>
-        <p:cNvPr id="1" name=""/>
-        <p:cNvGrpSpPr/>
-        <p:nvPr/>
-      </p:nvGrpSpPr>
-      <p:grpSpPr>
-        <a:xfrm>
-          <a:off x="0" y="0"/>
-          <a:ext cx="0" cy="0"/>
-          <a:chOff x="0" y="0"/>
-          <a:chExt cx="0" cy="0"/>
-        </a:xfrm>
-      </p:grpSpPr>
-      <p:pic>
-        <p:nvPicPr>
-          <p:cNvPr id="2" name="Picture 2"/>
-          <p:cNvPicPr>
-            <a:picLocks noChangeAspect="1"/>
-          </p:cNvPicPr>
-          <p:nvPr/>
-        </p:nvPicPr>
-        <p:blipFill>
-          <a:blip r:embed="rId2"/>
-          <a:stretch>
-            <a:fillRect/>
-          </a:stretch>
-        </p:blipFill>
-        <p:spPr>
-          <a:xfrm>
-            <a:off x="1155700" y="542925"/>
-            <a:ext cx="9976338" cy="5403850"/>
-          </a:xfrm>
-          <a:prstGeom prst="rect">
-            <a:avLst/>
-          </a:prstGeom>
-        </p:spPr>
-      </p:pic>
-    </p:spTree>
-  </p:cSld>
-  <p:clrMapOvr>
-    <a:masterClrMapping/>
-  </p:clrMapOvr>
-</p:sld>
-</file>
-
-<file path=ppt/slides/slide5.xml><?xml version="1.0" encoding="utf-8"?>
-<p:sld xmlns:a="http://schemas.openxmlformats.org/drawingml/2006/main" xmlns:r="http://schemas.openxmlformats.org/officeDocument/2006/relationships" xmlns:p="http://schemas.openxmlformats.org/presentationml/2006/main">
-  <p:cSld>
-    <p:spTree>
-      <p:nvGrpSpPr>
-        <p:cNvPr id="1" name=""/>
-        <p:cNvGrpSpPr/>
-        <p:nvPr/>
-      </p:nvGrpSpPr>
-      <p:grpSpPr>
-        <a:xfrm>
-          <a:off x="0" y="0"/>
-          <a:ext cx="0" cy="0"/>
-          <a:chOff x="0" y="0"/>
-          <a:chExt cx="0" cy="0"/>
-        </a:xfrm>
-      </p:grpSpPr>
-      <p:pic>
-        <p:nvPicPr>
-          <p:cNvPr id="2" name="Picture 2"/>
-          <p:cNvPicPr>
-            <a:picLocks noChangeAspect="1"/>
-          </p:cNvPicPr>
-          <p:nvPr/>
-        </p:nvPicPr>
-        <p:blipFill>
-          <a:blip r:embed="rId2"/>
-          <a:stretch>
-            <a:fillRect/>
-          </a:stretch>
-        </p:blipFill>
-        <p:spPr>
-          <a:xfrm>
-            <a:off x="1155700" y="542925"/>
-            <a:ext cx="9543136" cy="5403850"/>
-          </a:xfrm>
-          <a:prstGeom prst="rect">
-            <a:avLst/>
-          </a:prstGeom>
-        </p:spPr>
-      </p:pic>
-    </p:spTree>
-  </p:cSld>
-  <p:clrMapOvr>
-    <a:masterClrMapping/>
-  </p:clrMapOvr>
-</p:sld>
-</file>
-
-<file path=ppt/slides/slide6.xml><?xml version="1.0" encoding="utf-8"?>
-<p:sld xmlns:a="http://schemas.openxmlformats.org/drawingml/2006/main" xmlns:r="http://schemas.openxmlformats.org/officeDocument/2006/relationships" xmlns:p="http://schemas.openxmlformats.org/presentationml/2006/main">
-  <p:cSld>
-    <p:spTree>
-      <p:nvGrpSpPr>
-        <p:cNvPr id="1" name=""/>
-        <p:cNvGrpSpPr/>
-        <p:nvPr/>
-      </p:nvGrpSpPr>
-      <p:grpSpPr>
-        <a:xfrm>
-          <a:off x="0" y="0"/>
-          <a:ext cx="0" cy="0"/>
-          <a:chOff x="0" y="0"/>
-          <a:chExt cx="0" cy="0"/>
-        </a:xfrm>
-      </p:grpSpPr>
-      <p:pic>
-        <p:nvPicPr>
-          <p:cNvPr id="2" name="Picture 2"/>
-          <p:cNvPicPr>
-            <a:picLocks noChangeAspect="1"/>
-          </p:cNvPicPr>
-          <p:nvPr/>
-        </p:nvPicPr>
-        <p:blipFill>
-          <a:blip r:embed="rId2"/>
-          <a:stretch>
-            <a:fillRect/>
-          </a:stretch>
-        </p:blipFill>
-        <p:spPr>
-          <a:xfrm>
-            <a:off x="1155700" y="542925"/>
-            <a:ext cx="9543136" cy="5403850"/>
-          </a:xfrm>
-          <a:prstGeom prst="rect">
-            <a:avLst/>
-          </a:prstGeom>
-        </p:spPr>
-      </p:pic>
-    </p:spTree>
-  </p:cSld>
-  <p:clrMapOvr>
-    <a:masterClrMapping/>
-  </p:clrMapOvr>
-</p:sld>
-</file>
-
-<file path=ppt/slides/slide7.xml><?xml version="1.0" encoding="utf-8"?>
-<p:sld xmlns:a="http://schemas.openxmlformats.org/drawingml/2006/main" xmlns:r="http://schemas.openxmlformats.org/officeDocument/2006/relationships" xmlns:p="http://schemas.openxmlformats.org/presentationml/2006/main">
-  <p:cSld>
-    <p:spTree>
-      <p:nvGrpSpPr>
-        <p:cNvPr id="1" name=""/>
-        <p:cNvGrpSpPr/>
-        <p:nvPr/>
-      </p:nvGrpSpPr>
-      <p:grpSpPr>
-        <a:xfrm>
-          <a:off x="0" y="0"/>
-          <a:ext cx="0" cy="0"/>
-          <a:chOff x="0" y="0"/>
-          <a:chExt cx="0" cy="0"/>
-        </a:xfrm>
-      </p:grpSpPr>
-      <p:pic>
-        <p:nvPicPr>
-          <p:cNvPr id="2" name="Picture 2"/>
-          <p:cNvPicPr>
-            <a:picLocks noChangeAspect="1"/>
-          </p:cNvPicPr>
-          <p:nvPr/>
-        </p:nvPicPr>
-        <p:blipFill>
-          <a:blip r:embed="rId2"/>
-          <a:stretch>
-            <a:fillRect/>
-          </a:stretch>
-        </p:blipFill>
-        <p:spPr>
-          <a:xfrm>
-            <a:off x="1155700" y="542925"/>
-            <a:ext cx="9543136" cy="5403850"/>
-          </a:xfrm>
-          <a:prstGeom prst="rect">
-            <a:avLst/>
-          </a:prstGeom>
-        </p:spPr>
-      </p:pic>
-    </p:spTree>
-  </p:cSld>
-  <p:clrMapOvr>
-    <a:masterClrMapping/>
-  </p:clrMapOvr>
-</p:sld>
-</file>
-
-<file path=ppt/slides/slide8.xml><?xml version="1.0" encoding="utf-8"?>
-<p:sld xmlns:a="http://schemas.openxmlformats.org/drawingml/2006/main" xmlns:r="http://schemas.openxmlformats.org/officeDocument/2006/relationships" xmlns:p="http://schemas.openxmlformats.org/presentationml/2006/main">
-  <p:cSld>
-    <p:spTree>
-      <p:nvGrpSpPr>
-        <p:cNvPr id="1" name=""/>
-        <p:cNvGrpSpPr/>
-        <p:nvPr/>
-      </p:nvGrpSpPr>
-      <p:grpSpPr>
-        <a:xfrm>
-          <a:off x="0" y="0"/>
-          <a:ext cx="0" cy="0"/>
-          <a:chOff x="0" y="0"/>
-          <a:chExt cx="0" cy="0"/>
-        </a:xfrm>
-      </p:grpSpPr>
-      <p:pic>
-        <p:nvPicPr>
-          <p:cNvPr id="2" name="Picture 2"/>
-          <p:cNvPicPr>
-            <a:picLocks noChangeAspect="1"/>
-          </p:cNvPicPr>
-          <p:nvPr/>
-        </p:nvPicPr>
-        <p:blipFill>
-          <a:blip r:embed="rId2"/>
-          <a:stretch>
-            <a:fillRect/>
-          </a:stretch>
-        </p:blipFill>
-        <p:spPr>
-          <a:xfrm>
-            <a:off x="1155700" y="542925"/>
-            <a:ext cx="9543136" cy="5403850"/>
-          </a:xfrm>
-          <a:prstGeom prst="rect">
-            <a:avLst/>
-          </a:prstGeom>
-        </p:spPr>
-      </p:pic>
-    </p:spTree>
-  </p:cSld>
-  <p:clrMapOvr>
-    <a:masterClrMapping/>
-  </p:clrMapOvr>
-</p:sld>
-</file>
-
-<file path=ppt/slides/slide9.xml><?xml version="1.0" encoding="utf-8"?>
-<p:sld xmlns:a="http://schemas.openxmlformats.org/drawingml/2006/main" xmlns:r="http://schemas.openxmlformats.org/officeDocument/2006/relationships" xmlns:p="http://schemas.openxmlformats.org/presentationml/2006/main">
-  <p:cSld>
-    <p:spTree>
-      <p:nvGrpSpPr>
-        <p:cNvPr id="1" name=""/>
-        <p:cNvGrpSpPr/>
-        <p:nvPr/>
-      </p:nvGrpSpPr>
-      <p:grpSpPr>
-        <a:xfrm>
-          <a:off x="0" y="0"/>
-          <a:ext cx="0" cy="0"/>
-          <a:chOff x="0" y="0"/>
-          <a:chExt cx="0" cy="0"/>
-        </a:xfrm>
-      </p:grpSpPr>
-      <p:pic>
-        <p:nvPicPr>
-          <p:cNvPr id="2" name="Picture 2"/>
-          <p:cNvPicPr>
-            <a:picLocks noChangeAspect="1"/>
-          </p:cNvPicPr>
-          <p:nvPr/>
-        </p:nvPicPr>
-        <p:blipFill>
-          <a:blip r:embed="rId2"/>
-          <a:stretch>
-            <a:fillRect/>
-          </a:stretch>
-        </p:blipFill>
-        <p:spPr>
-          <a:xfrm>
-            <a:off x="1155700" y="542925"/>
-            <a:ext cx="9543136" cy="5403850"/>
-          </a:xfrm>
-          <a:prstGeom prst="rect">
-            <a:avLst/>
-          </a:prstGeom>
-        </p:spPr>
-      </p:pic>
-    </p:spTree>
   </p:cSld>
   <p:clrMapOvr>
     <a:masterClrMapping/>

</xml_diff>